<commit_message>
adiciona slide 'Outras Ferramentas' como penúltimo na apresentação
</commit_message>
<xml_diff>
--- a/IA_na_Sala_de_Aula_CDC_2026.pptx
+++ b/IA_na_Sala_de_Aula_CDC_2026.pptx
@@ -18,6 +18,7 @@
     <p:sldId id="263" r:id="rId11"/>
     <p:sldId id="264" r:id="rId12"/>
     <p:sldId id="265" r:id="rId13"/>
+    <p:sldId id="267" r:id="rId16"/>
     <p:sldId id="266" r:id="rId14"/>
   </p:sldIdLst>
   <p:sldSz cx="9144000" cy="5143500"/>
@@ -4021,6 +4022,1029 @@
       <p:transition spd="slow"/>
     </mc:Fallback>
   </mc:AlternateContent>
+</p:sld>
+</file>
+
+<file path=ppt/slides/slide12.xml><?xml version="1.0" encoding="utf-8"?>
+<p:sld xmlns:a="http://schemas.openxmlformats.org/drawingml/2006/main" xmlns:p="http://schemas.openxmlformats.org/presentationml/2006/main" xmlns:r="http://schemas.openxmlformats.org/officeDocument/2006/relationships">
+  <p:cSld>
+    <p:bg>
+      <p:bgPr>
+        <a:solidFill>
+          <a:srgbClr val="1A3A3A"/>
+        </a:solidFill>
+        <a:effectLst/>
+      </p:bgPr>
+    </p:bg>
+    <p:spTree>
+      <p:nvGrpSpPr>
+        <p:cNvPr id="1" name=""/>
+        <p:cNvGrpSpPr/>
+        <p:nvPr/>
+      </p:nvGrpSpPr>
+      <p:grpSpPr/>
+      <p:sp>
+        <p:nvSpPr>
+          <p:cNvPr id="2" name="Rectangle 1"/>
+          <p:cNvSpPr/>
+          <p:nvPr/>
+        </p:nvSpPr>
+        <p:spPr>
+          <a:xfrm>
+            <a:off x="0" y="0"/>
+            <a:ext cx="9144000" cy="54864"/>
+          </a:xfrm>
+          <a:prstGeom prst="rect">
+            <a:avLst/>
+          </a:prstGeom>
+          <a:solidFill>
+            <a:srgbClr val="D4A843"/>
+          </a:solidFill>
+          <a:ln>
+            <a:noFill/>
+          </a:ln>
+        </p:spPr>
+        <p:style>
+          <a:lnRef idx="1">
+            <a:schemeClr val="accent1"/>
+          </a:lnRef>
+          <a:fillRef idx="3">
+            <a:schemeClr val="accent1"/>
+          </a:fillRef>
+          <a:effectRef idx="2">
+            <a:schemeClr val="accent1"/>
+          </a:effectRef>
+          <a:fontRef idx="minor">
+            <a:schemeClr val="lt1"/>
+          </a:fontRef>
+        </p:style>
+        <p:txBody>
+          <a:bodyPr rtlCol="0" anchor="ctr"/>
+          <a:lstStyle/>
+          <a:p>
+            <a:pPr algn="ctr"/>
+          </a:p>
+        </p:txBody>
+      </p:sp>
+      <p:sp>
+        <p:nvSpPr>
+          <p:cNvPr id="3" name="Oval 2"/>
+          <p:cNvSpPr/>
+          <p:nvPr/>
+        </p:nvSpPr>
+        <p:spPr>
+          <a:xfrm>
+            <a:off x="-1371600" y="3200400"/>
+            <a:ext cx="3657600" cy="3657600"/>
+          </a:xfrm>
+          <a:prstGeom prst="ellipse">
+            <a:avLst/>
+          </a:prstGeom>
+          <a:solidFill>
+            <a:srgbClr val="C75B39">
+              <a:lumMod val="70000"/>
+              <a:lumOff val="30000"/>
+            </a:srgbClr>
+          </a:solidFill>
+          <a:ln>
+            <a:noFill/>
+          </a:ln>
+        </p:spPr>
+        <p:style>
+          <a:lnRef idx="1">
+            <a:schemeClr val="accent1"/>
+          </a:lnRef>
+          <a:fillRef idx="3">
+            <a:schemeClr val="accent1"/>
+          </a:fillRef>
+          <a:effectRef idx="2">
+            <a:schemeClr val="accent1"/>
+          </a:effectRef>
+          <a:fontRef idx="minor">
+            <a:schemeClr val="lt1"/>
+          </a:fontRef>
+        </p:style>
+        <p:txBody>
+          <a:bodyPr rtlCol="0" anchor="ctr"/>
+          <a:lstStyle/>
+          <a:p>
+            <a:pPr algn="ctr"/>
+          </a:p>
+        </p:txBody>
+      </p:sp>
+      <p:sp>
+        <p:nvSpPr>
+          <p:cNvPr id="4" name="Oval 3"/>
+          <p:cNvSpPr/>
+          <p:nvPr/>
+        </p:nvSpPr>
+        <p:spPr>
+          <a:xfrm>
+            <a:off x="7772400" y="-914400"/>
+            <a:ext cx="2743200" cy="2743200"/>
+          </a:xfrm>
+          <a:prstGeom prst="ellipse">
+            <a:avLst/>
+          </a:prstGeom>
+          <a:solidFill>
+            <a:srgbClr val="5B8C5A">
+              <a:lumMod val="60000"/>
+              <a:lumOff val="40000"/>
+            </a:srgbClr>
+          </a:solidFill>
+          <a:ln>
+            <a:noFill/>
+          </a:ln>
+        </p:spPr>
+        <p:style>
+          <a:lnRef idx="1">
+            <a:schemeClr val="accent1"/>
+          </a:lnRef>
+          <a:fillRef idx="3">
+            <a:schemeClr val="accent1"/>
+          </a:fillRef>
+          <a:effectRef idx="2">
+            <a:schemeClr val="accent1"/>
+          </a:effectRef>
+          <a:fontRef idx="minor">
+            <a:schemeClr val="lt1"/>
+          </a:fontRef>
+        </p:style>
+        <p:txBody>
+          <a:bodyPr rtlCol="0" anchor="ctr"/>
+          <a:lstStyle/>
+          <a:p>
+            <a:pPr algn="ctr"/>
+          </a:p>
+        </p:txBody>
+      </p:sp>
+      <p:sp>
+        <p:nvSpPr>
+          <p:cNvPr id="5" name="TextBox 4"/>
+          <p:cNvSpPr txBox="1"/>
+          <p:nvPr/>
+        </p:nvSpPr>
+        <p:spPr>
+          <a:xfrm>
+            <a:off x="731520" y="365760"/>
+            <a:ext cx="7680960" cy="640080"/>
+          </a:xfrm>
+          <a:prstGeom prst="rect">
+            <a:avLst/>
+          </a:prstGeom>
+          <a:noFill/>
+        </p:spPr>
+        <p:txBody>
+          <a:bodyPr wrap="square">
+            <a:spAutoFit/>
+          </a:bodyPr>
+          <a:lstStyle/>
+          <a:p>
+            <a:pPr algn="l">
+              <a:defRPr sz="2800" b="1" i="0">
+                <a:solidFill>
+                  <a:srgbClr val="FFFFFF"/>
+                </a:solidFill>
+                <a:latin typeface="Georgia"/>
+              </a:defRPr>
+            </a:pPr>
+            <a:r>
+              <a:t>Outras Ferramentas Deste Repositório</a:t>
+            </a:r>
+          </a:p>
+        </p:txBody>
+      </p:sp>
+      <p:sp>
+        <p:nvSpPr>
+          <p:cNvPr id="6" name="Rectangle 5"/>
+          <p:cNvSpPr/>
+          <p:nvPr/>
+        </p:nvSpPr>
+        <p:spPr>
+          <a:xfrm>
+            <a:off x="914400" y="1280160"/>
+            <a:ext cx="7315200" cy="548640"/>
+          </a:xfrm>
+          <a:prstGeom prst="rect">
+            <a:avLst/>
+          </a:prstGeom>
+          <a:solidFill>
+            <a:srgbClr val="FFFFFF"/>
+          </a:solidFill>
+          <a:ln>
+            <a:noFill/>
+          </a:ln>
+        </p:spPr>
+        <p:style>
+          <a:lnRef idx="1">
+            <a:schemeClr val="accent1"/>
+          </a:lnRef>
+          <a:fillRef idx="3">
+            <a:schemeClr val="accent1"/>
+          </a:fillRef>
+          <a:effectRef idx="2">
+            <a:schemeClr val="accent1"/>
+          </a:effectRef>
+          <a:fontRef idx="minor">
+            <a:schemeClr val="lt1"/>
+          </a:fontRef>
+        </p:style>
+        <p:txBody>
+          <a:bodyPr rtlCol="0" anchor="ctr"/>
+          <a:lstStyle/>
+          <a:p>
+            <a:pPr algn="ctr"/>
+          </a:p>
+        </p:txBody>
+      </p:sp>
+      <p:sp>
+        <p:nvSpPr>
+          <p:cNvPr id="7" name="Rectangle 6"/>
+          <p:cNvSpPr/>
+          <p:nvPr/>
+        </p:nvSpPr>
+        <p:spPr>
+          <a:xfrm>
+            <a:off x="914400" y="1280160"/>
+            <a:ext cx="54864" cy="548640"/>
+          </a:xfrm>
+          <a:prstGeom prst="rect">
+            <a:avLst/>
+          </a:prstGeom>
+          <a:solidFill>
+            <a:srgbClr val="C75B39"/>
+          </a:solidFill>
+          <a:ln>
+            <a:noFill/>
+          </a:ln>
+        </p:spPr>
+        <p:style>
+          <a:lnRef idx="1">
+            <a:schemeClr val="accent1"/>
+          </a:lnRef>
+          <a:fillRef idx="3">
+            <a:schemeClr val="accent1"/>
+          </a:fillRef>
+          <a:effectRef idx="2">
+            <a:schemeClr val="accent1"/>
+          </a:effectRef>
+          <a:fontRef idx="minor">
+            <a:schemeClr val="lt1"/>
+          </a:fontRef>
+        </p:style>
+        <p:txBody>
+          <a:bodyPr rtlCol="0" anchor="ctr"/>
+          <a:lstStyle/>
+          <a:p>
+            <a:pPr algn="ctr"/>
+          </a:p>
+        </p:txBody>
+      </p:sp>
+      <p:sp>
+        <p:nvSpPr>
+          <p:cNvPr id="8" name="TextBox 7"/>
+          <p:cNvSpPr txBox="1"/>
+          <p:nvPr/>
+        </p:nvSpPr>
+        <p:spPr>
+          <a:xfrm>
+            <a:off x="1097280" y="1325880"/>
+            <a:ext cx="1828800" cy="457200"/>
+          </a:xfrm>
+          <a:prstGeom prst="rect">
+            <a:avLst/>
+          </a:prstGeom>
+          <a:noFill/>
+        </p:spPr>
+        <p:txBody>
+          <a:bodyPr wrap="square">
+            <a:spAutoFit/>
+          </a:bodyPr>
+          <a:lstStyle/>
+          <a:p>
+            <a:pPr algn="l">
+              <a:defRPr sz="1600" b="1" i="0">
+                <a:solidFill>
+                  <a:srgbClr val="1A3A3A"/>
+                </a:solidFill>
+                <a:latin typeface="Georgia"/>
+              </a:defRPr>
+            </a:pPr>
+            <a:r>
+              <a:t>docx/</a:t>
+            </a:r>
+          </a:p>
+        </p:txBody>
+      </p:sp>
+      <p:sp>
+        <p:nvSpPr>
+          <p:cNvPr id="9" name="TextBox 8"/>
+          <p:cNvSpPr txBox="1"/>
+          <p:nvPr/>
+        </p:nvSpPr>
+        <p:spPr>
+          <a:xfrm>
+            <a:off x="2743200" y="1325880"/>
+            <a:ext cx="5303520" cy="457200"/>
+          </a:xfrm>
+          <a:prstGeom prst="rect">
+            <a:avLst/>
+          </a:prstGeom>
+          <a:noFill/>
+        </p:spPr>
+        <p:txBody>
+          <a:bodyPr wrap="square">
+            <a:spAutoFit/>
+          </a:bodyPr>
+          <a:lstStyle/>
+          <a:p>
+            <a:pPr algn="l">
+              <a:defRPr sz="1300" b="0" i="0">
+                <a:solidFill>
+                  <a:srgbClr val="5A5A5A"/>
+                </a:solidFill>
+                <a:latin typeface="Calibri"/>
+              </a:defRPr>
+            </a:pPr>
+            <a:r>
+              <a:t>Cria e edita documentos Word (.docx) com formatação profissional</a:t>
+            </a:r>
+          </a:p>
+        </p:txBody>
+      </p:sp>
+      <p:sp>
+        <p:nvSpPr>
+          <p:cNvPr id="10" name="Rectangle 9"/>
+          <p:cNvSpPr/>
+          <p:nvPr/>
+        </p:nvSpPr>
+        <p:spPr>
+          <a:xfrm>
+            <a:off x="914400" y="1965960"/>
+            <a:ext cx="7315200" cy="548640"/>
+          </a:xfrm>
+          <a:prstGeom prst="rect">
+            <a:avLst/>
+          </a:prstGeom>
+          <a:solidFill>
+            <a:srgbClr val="FFFFFF"/>
+          </a:solidFill>
+          <a:ln>
+            <a:noFill/>
+          </a:ln>
+        </p:spPr>
+        <p:style>
+          <a:lnRef idx="1">
+            <a:schemeClr val="accent1"/>
+          </a:lnRef>
+          <a:fillRef idx="3">
+            <a:schemeClr val="accent1"/>
+          </a:fillRef>
+          <a:effectRef idx="2">
+            <a:schemeClr val="accent1"/>
+          </a:effectRef>
+          <a:fontRef idx="minor">
+            <a:schemeClr val="lt1"/>
+          </a:fontRef>
+        </p:style>
+        <p:txBody>
+          <a:bodyPr rtlCol="0" anchor="ctr"/>
+          <a:lstStyle/>
+          <a:p>
+            <a:pPr algn="ctr"/>
+          </a:p>
+        </p:txBody>
+      </p:sp>
+      <p:sp>
+        <p:nvSpPr>
+          <p:cNvPr id="11" name="Rectangle 10"/>
+          <p:cNvSpPr/>
+          <p:nvPr/>
+        </p:nvSpPr>
+        <p:spPr>
+          <a:xfrm>
+            <a:off x="914400" y="1965960"/>
+            <a:ext cx="54864" cy="548640"/>
+          </a:xfrm>
+          <a:prstGeom prst="rect">
+            <a:avLst/>
+          </a:prstGeom>
+          <a:solidFill>
+            <a:srgbClr val="C75B39"/>
+          </a:solidFill>
+          <a:ln>
+            <a:noFill/>
+          </a:ln>
+        </p:spPr>
+        <p:style>
+          <a:lnRef idx="1">
+            <a:schemeClr val="accent1"/>
+          </a:lnRef>
+          <a:fillRef idx="3">
+            <a:schemeClr val="accent1"/>
+          </a:fillRef>
+          <a:effectRef idx="2">
+            <a:schemeClr val="accent1"/>
+          </a:effectRef>
+          <a:fontRef idx="minor">
+            <a:schemeClr val="lt1"/>
+          </a:fontRef>
+        </p:style>
+        <p:txBody>
+          <a:bodyPr rtlCol="0" anchor="ctr"/>
+          <a:lstStyle/>
+          <a:p>
+            <a:pPr algn="ctr"/>
+          </a:p>
+        </p:txBody>
+      </p:sp>
+      <p:sp>
+        <p:nvSpPr>
+          <p:cNvPr id="12" name="TextBox 11"/>
+          <p:cNvSpPr txBox="1"/>
+          <p:nvPr/>
+        </p:nvSpPr>
+        <p:spPr>
+          <a:xfrm>
+            <a:off x="1097280" y="2011680"/>
+            <a:ext cx="1828800" cy="457200"/>
+          </a:xfrm>
+          <a:prstGeom prst="rect">
+            <a:avLst/>
+          </a:prstGeom>
+          <a:noFill/>
+        </p:spPr>
+        <p:txBody>
+          <a:bodyPr wrap="square">
+            <a:spAutoFit/>
+          </a:bodyPr>
+          <a:lstStyle/>
+          <a:p>
+            <a:pPr algn="l">
+              <a:defRPr sz="1600" b="1" i="0">
+                <a:solidFill>
+                  <a:srgbClr val="1A3A3A"/>
+                </a:solidFill>
+                <a:latin typeface="Georgia"/>
+              </a:defRPr>
+            </a:pPr>
+            <a:r>
+              <a:t>xlsx/</a:t>
+            </a:r>
+          </a:p>
+        </p:txBody>
+      </p:sp>
+      <p:sp>
+        <p:nvSpPr>
+          <p:cNvPr id="13" name="TextBox 12"/>
+          <p:cNvSpPr txBox="1"/>
+          <p:nvPr/>
+        </p:nvSpPr>
+        <p:spPr>
+          <a:xfrm>
+            <a:off x="2743200" y="2011680"/>
+            <a:ext cx="5303520" cy="457200"/>
+          </a:xfrm>
+          <a:prstGeom prst="rect">
+            <a:avLst/>
+          </a:prstGeom>
+          <a:noFill/>
+        </p:spPr>
+        <p:txBody>
+          <a:bodyPr wrap="square">
+            <a:spAutoFit/>
+          </a:bodyPr>
+          <a:lstStyle/>
+          <a:p>
+            <a:pPr algn="l">
+              <a:defRPr sz="1300" b="0" i="0">
+                <a:solidFill>
+                  <a:srgbClr val="5A5A5A"/>
+                </a:solidFill>
+                <a:latin typeface="Calibri"/>
+              </a:defRPr>
+            </a:pPr>
+            <a:r>
+              <a:t>Cria e edita planilhas (.xlsx, .csv) com fórmulas, gráficos e formatação</a:t>
+            </a:r>
+          </a:p>
+        </p:txBody>
+      </p:sp>
+      <p:sp>
+        <p:nvSpPr>
+          <p:cNvPr id="14" name="Rectangle 13"/>
+          <p:cNvSpPr/>
+          <p:nvPr/>
+        </p:nvSpPr>
+        <p:spPr>
+          <a:xfrm>
+            <a:off x="914400" y="2651760"/>
+            <a:ext cx="7315200" cy="548640"/>
+          </a:xfrm>
+          <a:prstGeom prst="rect">
+            <a:avLst/>
+          </a:prstGeom>
+          <a:solidFill>
+            <a:srgbClr val="FFFFFF"/>
+          </a:solidFill>
+          <a:ln>
+            <a:noFill/>
+          </a:ln>
+        </p:spPr>
+        <p:style>
+          <a:lnRef idx="1">
+            <a:schemeClr val="accent1"/>
+          </a:lnRef>
+          <a:fillRef idx="3">
+            <a:schemeClr val="accent1"/>
+          </a:fillRef>
+          <a:effectRef idx="2">
+            <a:schemeClr val="accent1"/>
+          </a:effectRef>
+          <a:fontRef idx="minor">
+            <a:schemeClr val="lt1"/>
+          </a:fontRef>
+        </p:style>
+        <p:txBody>
+          <a:bodyPr rtlCol="0" anchor="ctr"/>
+          <a:lstStyle/>
+          <a:p>
+            <a:pPr algn="ctr"/>
+          </a:p>
+        </p:txBody>
+      </p:sp>
+      <p:sp>
+        <p:nvSpPr>
+          <p:cNvPr id="15" name="Rectangle 14"/>
+          <p:cNvSpPr/>
+          <p:nvPr/>
+        </p:nvSpPr>
+        <p:spPr>
+          <a:xfrm>
+            <a:off x="914400" y="2651760"/>
+            <a:ext cx="54864" cy="548640"/>
+          </a:xfrm>
+          <a:prstGeom prst="rect">
+            <a:avLst/>
+          </a:prstGeom>
+          <a:solidFill>
+            <a:srgbClr val="C75B39"/>
+          </a:solidFill>
+          <a:ln>
+            <a:noFill/>
+          </a:ln>
+        </p:spPr>
+        <p:style>
+          <a:lnRef idx="1">
+            <a:schemeClr val="accent1"/>
+          </a:lnRef>
+          <a:fillRef idx="3">
+            <a:schemeClr val="accent1"/>
+          </a:fillRef>
+          <a:effectRef idx="2">
+            <a:schemeClr val="accent1"/>
+          </a:effectRef>
+          <a:fontRef idx="minor">
+            <a:schemeClr val="lt1"/>
+          </a:fontRef>
+        </p:style>
+        <p:txBody>
+          <a:bodyPr rtlCol="0" anchor="ctr"/>
+          <a:lstStyle/>
+          <a:p>
+            <a:pPr algn="ctr"/>
+          </a:p>
+        </p:txBody>
+      </p:sp>
+      <p:sp>
+        <p:nvSpPr>
+          <p:cNvPr id="16" name="TextBox 15"/>
+          <p:cNvSpPr txBox="1"/>
+          <p:nvPr/>
+        </p:nvSpPr>
+        <p:spPr>
+          <a:xfrm>
+            <a:off x="1097280" y="2697480"/>
+            <a:ext cx="1828800" cy="457200"/>
+          </a:xfrm>
+          <a:prstGeom prst="rect">
+            <a:avLst/>
+          </a:prstGeom>
+          <a:noFill/>
+        </p:spPr>
+        <p:txBody>
+          <a:bodyPr wrap="square">
+            <a:spAutoFit/>
+          </a:bodyPr>
+          <a:lstStyle/>
+          <a:p>
+            <a:pPr algn="l">
+              <a:defRPr sz="1600" b="1" i="0">
+                <a:solidFill>
+                  <a:srgbClr val="1A3A3A"/>
+                </a:solidFill>
+                <a:latin typeface="Georgia"/>
+              </a:defRPr>
+            </a:pPr>
+            <a:r>
+              <a:t>pdf/</a:t>
+            </a:r>
+          </a:p>
+        </p:txBody>
+      </p:sp>
+      <p:sp>
+        <p:nvSpPr>
+          <p:cNvPr id="17" name="TextBox 16"/>
+          <p:cNvSpPr txBox="1"/>
+          <p:nvPr/>
+        </p:nvSpPr>
+        <p:spPr>
+          <a:xfrm>
+            <a:off x="2743200" y="2697480"/>
+            <a:ext cx="5303520" cy="457200"/>
+          </a:xfrm>
+          <a:prstGeom prst="rect">
+            <a:avLst/>
+          </a:prstGeom>
+          <a:noFill/>
+        </p:spPr>
+        <p:txBody>
+          <a:bodyPr wrap="square">
+            <a:spAutoFit/>
+          </a:bodyPr>
+          <a:lstStyle/>
+          <a:p>
+            <a:pPr algn="l">
+              <a:defRPr sz="1300" b="0" i="0">
+                <a:solidFill>
+                  <a:srgbClr val="5A5A5A"/>
+                </a:solidFill>
+                <a:latin typeface="Calibri"/>
+              </a:defRPr>
+            </a:pPr>
+            <a:r>
+              <a:t>Extrai texto, combina, divide, aplica OCR e preenche formulários PDF</a:t>
+            </a:r>
+          </a:p>
+        </p:txBody>
+      </p:sp>
+      <p:sp>
+        <p:nvSpPr>
+          <p:cNvPr id="18" name="Rectangle 17"/>
+          <p:cNvSpPr/>
+          <p:nvPr/>
+        </p:nvSpPr>
+        <p:spPr>
+          <a:xfrm>
+            <a:off x="914400" y="3337560"/>
+            <a:ext cx="7315200" cy="548640"/>
+          </a:xfrm>
+          <a:prstGeom prst="rect">
+            <a:avLst/>
+          </a:prstGeom>
+          <a:solidFill>
+            <a:srgbClr val="FFFFFF"/>
+          </a:solidFill>
+          <a:ln>
+            <a:noFill/>
+          </a:ln>
+        </p:spPr>
+        <p:style>
+          <a:lnRef idx="1">
+            <a:schemeClr val="accent1"/>
+          </a:lnRef>
+          <a:fillRef idx="3">
+            <a:schemeClr val="accent1"/>
+          </a:fillRef>
+          <a:effectRef idx="2">
+            <a:schemeClr val="accent1"/>
+          </a:effectRef>
+          <a:fontRef idx="minor">
+            <a:schemeClr val="lt1"/>
+          </a:fontRef>
+        </p:style>
+        <p:txBody>
+          <a:bodyPr rtlCol="0" anchor="ctr"/>
+          <a:lstStyle/>
+          <a:p>
+            <a:pPr algn="ctr"/>
+          </a:p>
+        </p:txBody>
+      </p:sp>
+      <p:sp>
+        <p:nvSpPr>
+          <p:cNvPr id="19" name="Rectangle 18"/>
+          <p:cNvSpPr/>
+          <p:nvPr/>
+        </p:nvSpPr>
+        <p:spPr>
+          <a:xfrm>
+            <a:off x="914400" y="3337560"/>
+            <a:ext cx="54864" cy="548640"/>
+          </a:xfrm>
+          <a:prstGeom prst="rect">
+            <a:avLst/>
+          </a:prstGeom>
+          <a:solidFill>
+            <a:srgbClr val="C75B39"/>
+          </a:solidFill>
+          <a:ln>
+            <a:noFill/>
+          </a:ln>
+        </p:spPr>
+        <p:style>
+          <a:lnRef idx="1">
+            <a:schemeClr val="accent1"/>
+          </a:lnRef>
+          <a:fillRef idx="3">
+            <a:schemeClr val="accent1"/>
+          </a:fillRef>
+          <a:effectRef idx="2">
+            <a:schemeClr val="accent1"/>
+          </a:effectRef>
+          <a:fontRef idx="minor">
+            <a:schemeClr val="lt1"/>
+          </a:fontRef>
+        </p:style>
+        <p:txBody>
+          <a:bodyPr rtlCol="0" anchor="ctr"/>
+          <a:lstStyle/>
+          <a:p>
+            <a:pPr algn="ctr"/>
+          </a:p>
+        </p:txBody>
+      </p:sp>
+      <p:sp>
+        <p:nvSpPr>
+          <p:cNvPr id="20" name="TextBox 19"/>
+          <p:cNvSpPr txBox="1"/>
+          <p:nvPr/>
+        </p:nvSpPr>
+        <p:spPr>
+          <a:xfrm>
+            <a:off x="1097280" y="3383280"/>
+            <a:ext cx="1828800" cy="457200"/>
+          </a:xfrm>
+          <a:prstGeom prst="rect">
+            <a:avLst/>
+          </a:prstGeom>
+          <a:noFill/>
+        </p:spPr>
+        <p:txBody>
+          <a:bodyPr wrap="square">
+            <a:spAutoFit/>
+          </a:bodyPr>
+          <a:lstStyle/>
+          <a:p>
+            <a:pPr algn="l">
+              <a:defRPr sz="1600" b="1" i="0">
+                <a:solidFill>
+                  <a:srgbClr val="1A3A3A"/>
+                </a:solidFill>
+                <a:latin typeface="Georgia"/>
+              </a:defRPr>
+            </a:pPr>
+            <a:r>
+              <a:t>pptx/</a:t>
+            </a:r>
+          </a:p>
+        </p:txBody>
+      </p:sp>
+      <p:sp>
+        <p:nvSpPr>
+          <p:cNvPr id="21" name="TextBox 20"/>
+          <p:cNvSpPr txBox="1"/>
+          <p:nvPr/>
+        </p:nvSpPr>
+        <p:spPr>
+          <a:xfrm>
+            <a:off x="2743200" y="3383280"/>
+            <a:ext cx="5303520" cy="457200"/>
+          </a:xfrm>
+          <a:prstGeom prst="rect">
+            <a:avLst/>
+          </a:prstGeom>
+          <a:noFill/>
+        </p:spPr>
+        <p:txBody>
+          <a:bodyPr wrap="square">
+            <a:spAutoFit/>
+          </a:bodyPr>
+          <a:lstStyle/>
+          <a:p>
+            <a:pPr algn="l">
+              <a:defRPr sz="1300" b="0" i="0">
+                <a:solidFill>
+                  <a:srgbClr val="5A5A5A"/>
+                </a:solidFill>
+                <a:latin typeface="Calibri"/>
+              </a:defRPr>
+            </a:pPr>
+            <a:r>
+              <a:t>Cria e edita apresentações de slides (.pptx) com design personalizado</a:t>
+            </a:r>
+          </a:p>
+        </p:txBody>
+      </p:sp>
+      <p:sp>
+        <p:nvSpPr>
+          <p:cNvPr id="22" name="Rectangle 21"/>
+          <p:cNvSpPr/>
+          <p:nvPr/>
+        </p:nvSpPr>
+        <p:spPr>
+          <a:xfrm>
+            <a:off x="914400" y="4023360"/>
+            <a:ext cx="7315200" cy="548640"/>
+          </a:xfrm>
+          <a:prstGeom prst="rect">
+            <a:avLst/>
+          </a:prstGeom>
+          <a:solidFill>
+            <a:srgbClr val="FFFFFF"/>
+          </a:solidFill>
+          <a:ln>
+            <a:noFill/>
+          </a:ln>
+        </p:spPr>
+        <p:style>
+          <a:lnRef idx="1">
+            <a:schemeClr val="accent1"/>
+          </a:lnRef>
+          <a:fillRef idx="3">
+            <a:schemeClr val="accent1"/>
+          </a:fillRef>
+          <a:effectRef idx="2">
+            <a:schemeClr val="accent1"/>
+          </a:effectRef>
+          <a:fontRef idx="minor">
+            <a:schemeClr val="lt1"/>
+          </a:fontRef>
+        </p:style>
+        <p:txBody>
+          <a:bodyPr rtlCol="0" anchor="ctr"/>
+          <a:lstStyle/>
+          <a:p>
+            <a:pPr algn="ctr"/>
+          </a:p>
+        </p:txBody>
+      </p:sp>
+      <p:sp>
+        <p:nvSpPr>
+          <p:cNvPr id="23" name="Rectangle 22"/>
+          <p:cNvSpPr/>
+          <p:nvPr/>
+        </p:nvSpPr>
+        <p:spPr>
+          <a:xfrm>
+            <a:off x="914400" y="4023360"/>
+            <a:ext cx="54864" cy="548640"/>
+          </a:xfrm>
+          <a:prstGeom prst="rect">
+            <a:avLst/>
+          </a:prstGeom>
+          <a:solidFill>
+            <a:srgbClr val="C75B39"/>
+          </a:solidFill>
+          <a:ln>
+            <a:noFill/>
+          </a:ln>
+        </p:spPr>
+        <p:style>
+          <a:lnRef idx="1">
+            <a:schemeClr val="accent1"/>
+          </a:lnRef>
+          <a:fillRef idx="3">
+            <a:schemeClr val="accent1"/>
+          </a:fillRef>
+          <a:effectRef idx="2">
+            <a:schemeClr val="accent1"/>
+          </a:effectRef>
+          <a:fontRef idx="minor">
+            <a:schemeClr val="lt1"/>
+          </a:fontRef>
+        </p:style>
+        <p:txBody>
+          <a:bodyPr rtlCol="0" anchor="ctr"/>
+          <a:lstStyle/>
+          <a:p>
+            <a:pPr algn="ctr"/>
+          </a:p>
+        </p:txBody>
+      </p:sp>
+      <p:sp>
+        <p:nvSpPr>
+          <p:cNvPr id="24" name="TextBox 23"/>
+          <p:cNvSpPr txBox="1"/>
+          <p:nvPr/>
+        </p:nvSpPr>
+        <p:spPr>
+          <a:xfrm>
+            <a:off x="1097280" y="4069080"/>
+            <a:ext cx="1828800" cy="457200"/>
+          </a:xfrm>
+          <a:prstGeom prst="rect">
+            <a:avLst/>
+          </a:prstGeom>
+          <a:noFill/>
+        </p:spPr>
+        <p:txBody>
+          <a:bodyPr wrap="square">
+            <a:spAutoFit/>
+          </a:bodyPr>
+          <a:lstStyle/>
+          <a:p>
+            <a:pPr algn="l">
+              <a:defRPr sz="1600" b="1" i="0">
+                <a:solidFill>
+                  <a:srgbClr val="1A3A3A"/>
+                </a:solidFill>
+                <a:latin typeface="Georgia"/>
+              </a:defRPr>
+            </a:pPr>
+            <a:r>
+              <a:t>skill-creator/</a:t>
+            </a:r>
+          </a:p>
+        </p:txBody>
+      </p:sp>
+      <p:sp>
+        <p:nvSpPr>
+          <p:cNvPr id="25" name="TextBox 24"/>
+          <p:cNvSpPr txBox="1"/>
+          <p:nvPr/>
+        </p:nvSpPr>
+        <p:spPr>
+          <a:xfrm>
+            <a:off x="2743200" y="4069080"/>
+            <a:ext cx="5303520" cy="457200"/>
+          </a:xfrm>
+          <a:prstGeom prst="rect">
+            <a:avLst/>
+          </a:prstGeom>
+          <a:noFill/>
+        </p:spPr>
+        <p:txBody>
+          <a:bodyPr wrap="square">
+            <a:spAutoFit/>
+          </a:bodyPr>
+          <a:lstStyle/>
+          <a:p>
+            <a:pPr algn="l">
+              <a:defRPr sz="1300" b="0" i="0">
+                <a:solidFill>
+                  <a:srgbClr val="5A5A5A"/>
+                </a:solidFill>
+                <a:latin typeface="Calibri"/>
+              </a:defRPr>
+            </a:pPr>
+            <a:r>
+              <a:t>Cria, edita e testa skills com avaliação automatizada de desempenho</a:t>
+            </a:r>
+          </a:p>
+        </p:txBody>
+      </p:sp>
+      <p:sp>
+        <p:nvSpPr>
+          <p:cNvPr id="26" name="TextBox 25"/>
+          <p:cNvSpPr txBox="1"/>
+          <p:nvPr/>
+        </p:nvSpPr>
+        <p:spPr>
+          <a:xfrm>
+            <a:off x="731520" y="4572000"/>
+            <a:ext cx="7680960" cy="365760"/>
+          </a:xfrm>
+          <a:prstGeom prst="rect">
+            <a:avLst/>
+          </a:prstGeom>
+          <a:noFill/>
+        </p:spPr>
+        <p:txBody>
+          <a:bodyPr wrap="square">
+            <a:spAutoFit/>
+          </a:bodyPr>
+          <a:lstStyle/>
+          <a:p>
+            <a:pPr algn="ctr">
+              <a:defRPr sz="1200" b="0" i="1">
+                <a:solidFill>
+                  <a:srgbClr val="D4A843"/>
+                </a:solidFill>
+                <a:latin typeface="Calibri"/>
+              </a:defRPr>
+            </a:pPr>
+            <a:r>
+              <a:t>Use a skill pptx/ para criar ou editar apresentações como esta!</a:t>
+            </a:r>
+          </a:p>
+        </p:txBody>
+      </p:sp>
+    </p:spTree>
+  </p:cSld>
+  <p:clrMapOvr>
+    <a:masterClrMapping/>
+  </p:clrMapOvr>
 </p:sld>
 </file>
 

</xml_diff>